<commit_message>
feat: update Week 3, Session 1 scripts by enhancing the HTTP request handling for fetching Wikimedia diagrams, improving reliability with retry logic, and updating the diagram fetching function for better performance
</commit_message>
<xml_diff>
--- a/web-presentation/pdf-exports/Week3-Session1-NLP.pptx
+++ b/web-presentation/pdf-exports/Week3-Session1-NLP.pptx
@@ -19249,8 +19249,8 @@
         </p:blipFill>
         <p:spPr>
           <a:xfrm>
-            <a:off x="2817121" y="2194560"/>
-            <a:ext cx="6435836" cy="4050791"/>
+            <a:off x="1882748" y="2194560"/>
+            <a:ext cx="8304582" cy="4050791"/>
           </a:xfrm>
           <a:prstGeom prst="rect">
             <a:avLst/>
@@ -27338,8 +27338,8 @@
         </p:blipFill>
         <p:spPr>
           <a:xfrm>
-            <a:off x="731520" y="2134305"/>
-            <a:ext cx="10607040" cy="3823830"/>
+            <a:off x="731520" y="2279485"/>
+            <a:ext cx="10607040" cy="3533470"/>
           </a:xfrm>
           <a:prstGeom prst="rect">
             <a:avLst/>
@@ -28533,8 +28533,8 @@
         </p:blipFill>
         <p:spPr>
           <a:xfrm>
-            <a:off x="731520" y="2036957"/>
-            <a:ext cx="10607040" cy="4018526"/>
+            <a:off x="1086219" y="1847088"/>
+            <a:ext cx="9897640" cy="4398264"/>
           </a:xfrm>
           <a:prstGeom prst="rect">
             <a:avLst/>
@@ -30787,8 +30787,8 @@
         </p:blipFill>
         <p:spPr>
           <a:xfrm>
-            <a:off x="731520" y="2036957"/>
-            <a:ext cx="10607040" cy="4018526"/>
+            <a:off x="1712421" y="1847088"/>
+            <a:ext cx="8645236" cy="4398264"/>
           </a:xfrm>
           <a:prstGeom prst="rect">
             <a:avLst/>
@@ -31224,8 +31224,8 @@
         </p:blipFill>
         <p:spPr>
           <a:xfrm>
-            <a:off x="2808138" y="2194560"/>
-            <a:ext cx="6453802" cy="4050791"/>
+            <a:off x="4009644" y="2194560"/>
+            <a:ext cx="4050791" cy="4050791"/>
           </a:xfrm>
           <a:prstGeom prst="rect">
             <a:avLst/>
@@ -32347,8 +32347,8 @@
         </p:blipFill>
         <p:spPr>
           <a:xfrm>
-            <a:off x="731520" y="2036957"/>
-            <a:ext cx="10607040" cy="4018526"/>
+            <a:off x="1712421" y="1847088"/>
+            <a:ext cx="8645236" cy="4398264"/>
           </a:xfrm>
           <a:prstGeom prst="rect">
             <a:avLst/>
@@ -33336,8 +33336,8 @@
         </p:blipFill>
         <p:spPr>
           <a:xfrm>
-            <a:off x="731520" y="2009699"/>
-            <a:ext cx="10607040" cy="4073041"/>
+            <a:off x="4542105" y="1847088"/>
+            <a:ext cx="2985869" cy="4398264"/>
           </a:xfrm>
           <a:prstGeom prst="rect">
             <a:avLst/>
@@ -35059,8 +35059,8 @@
         </p:blipFill>
         <p:spPr>
           <a:xfrm>
-            <a:off x="760491" y="2194560"/>
-            <a:ext cx="10549096" cy="4050791"/>
+            <a:off x="4660050" y="2194560"/>
+            <a:ext cx="2749978" cy="4050791"/>
           </a:xfrm>
           <a:prstGeom prst="rect">
             <a:avLst/>

</xml_diff>

<commit_message>
feat: update Week 3, Session 1 PowerPoint and scripts by adding new diagram fetching functionality for Wikimedia SVG thumbnails, enhancing the reliability of visual content retrieval and improving educational resources on NLP topics
</commit_message>
<xml_diff>
--- a/web-presentation/pdf-exports/Week3-Session1-NLP.pptx
+++ b/web-presentation/pdf-exports/Week3-Session1-NLP.pptx
@@ -27338,8 +27338,8 @@
         </p:blipFill>
         <p:spPr>
           <a:xfrm>
-            <a:off x="731520" y="2279485"/>
-            <a:ext cx="10607040" cy="3533470"/>
+            <a:off x="731520" y="2278380"/>
+            <a:ext cx="10607040" cy="3535680"/>
           </a:xfrm>
           <a:prstGeom prst="rect">
             <a:avLst/>
@@ -28533,8 +28533,8 @@
         </p:blipFill>
         <p:spPr>
           <a:xfrm>
-            <a:off x="1086219" y="1847088"/>
-            <a:ext cx="9897640" cy="4398264"/>
+            <a:off x="1086993" y="1847088"/>
+            <a:ext cx="9896094" cy="4398264"/>
           </a:xfrm>
           <a:prstGeom prst="rect">
             <a:avLst/>

</xml_diff>